<commit_message>
Refaz os slides do seminário com identidade editorial própria
21 slides com layouts próprios: tipografia (Inter Tight, Instrument Serif,
JetBrains Mono), paleta creme/cobalto/soro e diagramas vetoriais
(fluxograma em linhas de metrô, matriz de efeitos, transição vítrea).
PPTX com roteiro de fala nas anotações; dossiê com a nova divisão de falas.

Co-Authored-By: Claude Opus 5.5 <noreply@anthropic.com>
Claude-Session: https://claude.ai/code/session_017sLVebVys6WDLqT6dU1HLg
</commit_message>
<xml_diff>
--- a/seminario-whey-protein/Apresentacao_Whey_Protein_Concentrado.pptx
+++ b/seminario-whey-protein/Apresentacao_Whey_Protein_Concentrado.pptx
@@ -22,6 +22,10 @@
     <p:sldId id="270" r:id="rId22"/>
     <p:sldId id="271" r:id="rId23"/>
     <p:sldId id="272" r:id="rId24"/>
+    <p:sldId id="273" r:id="rId25"/>
+    <p:sldId id="274" r:id="rId26"/>
+    <p:sldId id="275" r:id="rId27"/>
+    <p:sldId id="276" r:id="rId28"/>
   </p:sldIdLst>
   <p:sldSz cx="12192000" cy="6858000" type="screen4x3"/>
   <p:notesSz cx="6858000" cy="9144000"/>
@@ -518,7 +522,7 @@
           <a:lstStyle/>
           <a:p>
             <a:r>
-              <a:t>[Bruna] Apresentar o grupo e o tema: whey protein concentrado (WPC), a proteína do soro do leite que virou suplemento.</a:t>
+              <a:t>[Bruna] Bom dia. Somos o Grupo 1 e vamos falar do whey protein concentrado. O gráfico de pontos mostra o que tem em 100 g de WPC80: cada ponto é 1 grama — 80 são proteína.</a:t>
             </a:r>
           </a:p>
         </p:txBody>
@@ -588,7 +592,7 @@
           <a:lstStyle/>
           <a:p>
             <a:r>
-              <a:t>[Renan] Perigos biológicos, químicos e físicos e seus controles. PCCs: pasteurização e detector de metais. Salmonella e Cronobacter não crescem no pó, mas sobrevivem — por isso a higiene da área seca é essencial.</a:t>
+              <a:t>[Gabriel] O processo tem duas fábricas. A linha azul é o laticínio: recepção e resfriamento do soro, clarificação, desnate, pasteurização (que é PCC), resfriamento, ultrafiltração e diafiltração, concentração, spray drying, aglomeração e detector de metais (outro PCC). O WPC80 em pó vira insumo da segunda fábrica, a de suplementos (linha preta): recepção, pesagem, mistura, detector de metais, envase, rotulagem e estoque.</a:t>
             </a:r>
           </a:p>
         </p:txBody>
@@ -658,7 +662,7 @@
           <a:lstStyle/>
           <a:p>
             <a:r>
-              <a:t>[Renan] Conservação: umidade causa empedramento (transição vítrea da lactose); calor acelera Maillard; oxigênio e luz oxidam a gordura. Embalagem com barreira e dicas para o consumidor.</a:t>
+              <a:t>[Gabriel] Três etapas definem o WPC. A pasteurização, a 72–75 °C por 15–20 s, elimina patógenos com pouca desnaturação. A ultrafiltração segura a proteína e deixa passar lactose e sais; a diafiltração lava o retido com água. No spray drying, o ar entra a 175–200 °C, mas a gota fica fria enquanto evapora. Passo para o Renan.</a:t>
             </a:r>
           </a:p>
         </p:txBody>
@@ -728,7 +732,7 @@
           <a:lstStyle/>
           <a:p>
             <a:r>
-              <a:t>[Pedro] Mercado: estudo da UFMG com 88% das marcas com erro de rótulo e uma com proteína 35% abaixo da tolerância; Recife: só 2 de 14 conformes; ANVISA 2025 suspendeu lote com glúten não declarado. Explicar amino spiking.</a:t>
+              <a:t>[Renan] Esta matriz mostra o que cada etapa muda: efeitos físicos, químicos, microbiológicos, sensoriais e nutricionais. Os dois pontos destacados são a reação de Maillard e a perda de lisina disponível, que acontecem principalmente na estocagem. E tudo depende de temperatura, tempo, umidade, oxigênio e formulação.</a:t>
             </a:r>
           </a:p>
         </p:txBody>
@@ -798,7 +802,7 @@
           <a:lstStyle/>
           <a:p>
             <a:r>
-              <a:t>[Pedro] Vantagens e limitações, considerando frequência, contexto, lactose e o debate sobre ultraprocessados — sem classificações simplistas.</a:t>
+              <a:t>[Renan] Um ponto importante para não generalizar: desnaturar não é estragar. O calor muda a forma da proteína, mas os aminoácidos continuam lá. A perda real vem da reação de Maillard, quando a lactose se liga à lisina e o corpo deixa de aproveitá-la.</a:t>
             </a:r>
           </a:p>
         </p:txBody>
@@ -868,7 +872,7 @@
           <a:lstStyle/>
           <a:p>
             <a:r>
-              <a:t>[Pedro] Posicionamento: nem vilão, nem indispensável. Pode entrar como complemento quando há necessidade real, com nutricionista e produto regularizado.</a:t>
+              <a:t>[Renan] Perigos biológicos, químicos e físicos e seus controles. Os PCCs são a pasteurização e o detector de metais. A base são as boas práticas e os POPs. E um alerta: Salmonella e Cronobacter não crescem no pó, mas sobrevivem por meses.</a:t>
             </a:r>
           </a:p>
         </p:txBody>
@@ -938,7 +942,7 @@
           <a:lstStyle/>
           <a:p>
             <a:r>
-              <a:t>Referências (legislação e estudos brasileiros).</a:t>
+              <a:t>[Renan] Conservação: o inimigo do pó é a água. Quando o pó ganha umidade ou calor, passa da transição vítrea, fica pegajoso, empedra e a Maillard acelera. Por isso: embalagem com barreira, pote bem fechado, dosador seco e local fresco. Passo para o Pedro.</a:t>
             </a:r>
           </a:p>
         </p:txBody>
@@ -1008,7 +1012,7 @@
           <a:lstStyle/>
           <a:p>
             <a:r>
-              <a:t>Referências (artigos e livros).</a:t>
+              <a:t>[Pedro] O rótulo nem sempre conta a verdade. Um estudo da UFMG achou erro de rótulo em 88% das marcas e uma marca com proteína 35% abaixo da tolerância. Em Recife, só 2 de 14 amostras estavam totalmente conformes. Em 2025, a ANVISA suspendeu um lote com glúten não declarado. E existe a fraude do amino spiking, que infla a proteína no laudo.</a:t>
             </a:r>
           </a:p>
         </p:txBody>
@@ -1078,7 +1082,147 @@
           <a:lstStyle/>
           <a:p>
             <a:r>
-              <a:t>Agradecer e abrir para perguntas. Respostas prontas na seção 7 do dossiê.</a:t>
+              <a:t>[Pedro] Vale a pena? Depende. A favor: proteína de alta qualidade, praticidade, ajuda quando a comida não basta e aproveita um resíduo. Contra: não é indispensável, o saborizado é ultraprocessado, tem lactose e é alergênico, e o mercado tem falhas. O contexto importa: frequência, dose e quem vai usar.</a:t>
+            </a:r>
+          </a:p>
+        </p:txBody>
+      </p:sp>
+      <p:sp>
+        <p:nvSpPr>
+          <p:cNvPr id="4" name="Slide Number Placeholder 3"/>
+          <p:cNvSpPr>
+            <a:spLocks noGrp="1"/>
+          </p:cNvSpPr>
+          <p:nvPr>
+            <p:ph type="sldNum" idx="5" sz="quarter"/>
+          </p:nvPr>
+        </p:nvSpPr>
+        <p:spPr/>
+      </p:sp>
+    </p:spTree>
+  </p:cSld>
+  <p:clrMapOvr>
+    <a:masterClrMapping/>
+  </p:clrMapOvr>
+</p:notes>
+</file>
+
+<file path=ppt/notesSlides/notesSlide18.xml><?xml version="1.0" encoding="utf-8"?>
+<p:notes xmlns:a="http://schemas.openxmlformats.org/drawingml/2006/main" xmlns:p="http://schemas.openxmlformats.org/presentationml/2006/main" xmlns:r="http://schemas.openxmlformats.org/officeDocument/2006/relationships">
+  <p:cSld>
+    <p:spTree>
+      <p:nvGrpSpPr>
+        <p:cNvPr id="1" name=""/>
+        <p:cNvGrpSpPr/>
+        <p:nvPr/>
+      </p:nvGrpSpPr>
+      <p:grpSpPr>
+        <a:xfrm>
+          <a:off x="0" y="0"/>
+          <a:ext cx="0" cy="0"/>
+          <a:chOff x="0" y="0"/>
+          <a:chExt cx="0" cy="0"/>
+        </a:xfrm>
+      </p:grpSpPr>
+      <p:sp>
+        <p:nvSpPr>
+          <p:cNvPr id="2" name="Slide Image Placeholder 1"/>
+          <p:cNvSpPr>
+            <a:spLocks noGrp="1"/>
+          </p:cNvSpPr>
+          <p:nvPr>
+            <p:ph type="sldImg" idx="2"/>
+          </p:nvPr>
+        </p:nvSpPr>
+        <p:spPr/>
+      </p:sp>
+      <p:sp>
+        <p:nvSpPr>
+          <p:cNvPr id="3" name="Notes Placeholder 2"/>
+          <p:cNvSpPr>
+            <a:spLocks noGrp="1"/>
+          </p:cNvSpPr>
+          <p:nvPr>
+            <p:ph type="body" idx="3" sz="quarter"/>
+          </p:nvPr>
+        </p:nvSpPr>
+        <p:spPr/>
+        <p:txBody>
+          <a:bodyPr/>
+          <a:lstStyle/>
+          <a:p>
+            <a:r>
+              <a:t>[Pedro] Nossa conclusão: nem vilão, nem indispensável. O whey pode entrar na alimentação cotidiana quando complementa as refeições, quando existe necessidade real avaliada por nutricionista, e quando o produto é notificado e o rótulo foi conferido.</a:t>
+            </a:r>
+          </a:p>
+        </p:txBody>
+      </p:sp>
+      <p:sp>
+        <p:nvSpPr>
+          <p:cNvPr id="4" name="Slide Number Placeholder 3"/>
+          <p:cNvSpPr>
+            <a:spLocks noGrp="1"/>
+          </p:cNvSpPr>
+          <p:nvPr>
+            <p:ph type="sldNum" idx="5" sz="quarter"/>
+          </p:nvPr>
+        </p:nvSpPr>
+        <p:spPr/>
+      </p:sp>
+    </p:spTree>
+  </p:cSld>
+  <p:clrMapOvr>
+    <a:masterClrMapping/>
+  </p:clrMapOvr>
+</p:notes>
+</file>
+
+<file path=ppt/notesSlides/notesSlide19.xml><?xml version="1.0" encoding="utf-8"?>
+<p:notes xmlns:a="http://schemas.openxmlformats.org/drawingml/2006/main" xmlns:p="http://schemas.openxmlformats.org/presentationml/2006/main" xmlns:r="http://schemas.openxmlformats.org/officeDocument/2006/relationships">
+  <p:cSld>
+    <p:spTree>
+      <p:nvGrpSpPr>
+        <p:cNvPr id="1" name=""/>
+        <p:cNvGrpSpPr/>
+        <p:nvPr/>
+      </p:nvGrpSpPr>
+      <p:grpSpPr>
+        <a:xfrm>
+          <a:off x="0" y="0"/>
+          <a:ext cx="0" cy="0"/>
+          <a:chOff x="0" y="0"/>
+          <a:chExt cx="0" cy="0"/>
+        </a:xfrm>
+      </p:grpSpPr>
+      <p:sp>
+        <p:nvSpPr>
+          <p:cNvPr id="2" name="Slide Image Placeholder 1"/>
+          <p:cNvSpPr>
+            <a:spLocks noGrp="1"/>
+          </p:cNvSpPr>
+          <p:nvPr>
+            <p:ph type="sldImg" idx="2"/>
+          </p:nvPr>
+        </p:nvSpPr>
+        <p:spPr/>
+      </p:sp>
+      <p:sp>
+        <p:nvSpPr>
+          <p:cNvPr id="3" name="Notes Placeholder 2"/>
+          <p:cNvSpPr>
+            <a:spLocks noGrp="1"/>
+          </p:cNvSpPr>
+          <p:nvPr>
+            <p:ph type="body" idx="3" sz="quarter"/>
+          </p:nvPr>
+        </p:nvSpPr>
+        <p:spPr/>
+        <p:txBody>
+          <a:bodyPr/>
+          <a:lstStyle/>
+          <a:p>
+            <a:r>
+              <a:t>Referências — legislação.</a:t>
             </a:r>
           </a:p>
         </p:txBody>
@@ -1148,7 +1292,147 @@
           <a:lstStyle/>
           <a:p>
             <a:r>
-              <a:t>[Bruna] Roteiro: seguimos os 6 tópicos pedidos — caracterização, composição e rótulo, fluxograma, efeitos do processamento, segurança e conservação, análise crítica.</a:t>
+              <a:t>[Bruna] Organizamos a apresentação em seis perguntas, uma para cada tópico pedido. Eu começo com o que é o whey e quem consome.</a:t>
+            </a:r>
+          </a:p>
+        </p:txBody>
+      </p:sp>
+      <p:sp>
+        <p:nvSpPr>
+          <p:cNvPr id="4" name="Slide Number Placeholder 3"/>
+          <p:cNvSpPr>
+            <a:spLocks noGrp="1"/>
+          </p:cNvSpPr>
+          <p:nvPr>
+            <p:ph type="sldNum" idx="5" sz="quarter"/>
+          </p:nvPr>
+        </p:nvSpPr>
+        <p:spPr/>
+      </p:sp>
+    </p:spTree>
+  </p:cSld>
+  <p:clrMapOvr>
+    <a:masterClrMapping/>
+  </p:clrMapOvr>
+</p:notes>
+</file>
+
+<file path=ppt/notesSlides/notesSlide20.xml><?xml version="1.0" encoding="utf-8"?>
+<p:notes xmlns:a="http://schemas.openxmlformats.org/drawingml/2006/main" xmlns:p="http://schemas.openxmlformats.org/presentationml/2006/main" xmlns:r="http://schemas.openxmlformats.org/officeDocument/2006/relationships">
+  <p:cSld>
+    <p:spTree>
+      <p:nvGrpSpPr>
+        <p:cNvPr id="1" name=""/>
+        <p:cNvGrpSpPr/>
+        <p:nvPr/>
+      </p:nvGrpSpPr>
+      <p:grpSpPr>
+        <a:xfrm>
+          <a:off x="0" y="0"/>
+          <a:ext cx="0" cy="0"/>
+          <a:chOff x="0" y="0"/>
+          <a:chExt cx="0" cy="0"/>
+        </a:xfrm>
+      </p:grpSpPr>
+      <p:sp>
+        <p:nvSpPr>
+          <p:cNvPr id="2" name="Slide Image Placeholder 1"/>
+          <p:cNvSpPr>
+            <a:spLocks noGrp="1"/>
+          </p:cNvSpPr>
+          <p:nvPr>
+            <p:ph type="sldImg" idx="2"/>
+          </p:nvPr>
+        </p:nvSpPr>
+        <p:spPr/>
+      </p:sp>
+      <p:sp>
+        <p:nvSpPr>
+          <p:cNvPr id="3" name="Notes Placeholder 2"/>
+          <p:cNvSpPr>
+            <a:spLocks noGrp="1"/>
+          </p:cNvSpPr>
+          <p:nvPr>
+            <p:ph type="body" idx="3" sz="quarter"/>
+          </p:nvPr>
+        </p:nvSpPr>
+        <p:spPr/>
+        <p:txBody>
+          <a:bodyPr/>
+          <a:lstStyle/>
+          <a:p>
+            <a:r>
+              <a:t>Referências — artigos, livros e dados.</a:t>
+            </a:r>
+          </a:p>
+        </p:txBody>
+      </p:sp>
+      <p:sp>
+        <p:nvSpPr>
+          <p:cNvPr id="4" name="Slide Number Placeholder 3"/>
+          <p:cNvSpPr>
+            <a:spLocks noGrp="1"/>
+          </p:cNvSpPr>
+          <p:nvPr>
+            <p:ph type="sldNum" idx="5" sz="quarter"/>
+          </p:nvPr>
+        </p:nvSpPr>
+        <p:spPr/>
+      </p:sp>
+    </p:spTree>
+  </p:cSld>
+  <p:clrMapOvr>
+    <a:masterClrMapping/>
+  </p:clrMapOvr>
+</p:notes>
+</file>
+
+<file path=ppt/notesSlides/notesSlide21.xml><?xml version="1.0" encoding="utf-8"?>
+<p:notes xmlns:a="http://schemas.openxmlformats.org/drawingml/2006/main" xmlns:p="http://schemas.openxmlformats.org/presentationml/2006/main" xmlns:r="http://schemas.openxmlformats.org/officeDocument/2006/relationships">
+  <p:cSld>
+    <p:spTree>
+      <p:nvGrpSpPr>
+        <p:cNvPr id="1" name=""/>
+        <p:cNvGrpSpPr/>
+        <p:nvPr/>
+      </p:nvGrpSpPr>
+      <p:grpSpPr>
+        <a:xfrm>
+          <a:off x="0" y="0"/>
+          <a:ext cx="0" cy="0"/>
+          <a:chOff x="0" y="0"/>
+          <a:chExt cx="0" cy="0"/>
+        </a:xfrm>
+      </p:grpSpPr>
+      <p:sp>
+        <p:nvSpPr>
+          <p:cNvPr id="2" name="Slide Image Placeholder 1"/>
+          <p:cNvSpPr>
+            <a:spLocks noGrp="1"/>
+          </p:cNvSpPr>
+          <p:nvPr>
+            <p:ph type="sldImg" idx="2"/>
+          </p:nvPr>
+        </p:nvSpPr>
+        <p:spPr/>
+      </p:sp>
+      <p:sp>
+        <p:nvSpPr>
+          <p:cNvPr id="3" name="Notes Placeholder 2"/>
+          <p:cNvSpPr>
+            <a:spLocks noGrp="1"/>
+          </p:cNvSpPr>
+          <p:nvPr>
+            <p:ph type="body" idx="3" sz="quarter"/>
+          </p:nvPr>
+        </p:nvSpPr>
+        <p:spPr/>
+        <p:txBody>
+          <a:bodyPr/>
+          <a:lstStyle/>
+          <a:p>
+            <a:r>
+              <a:t>[Todos] Agradecer e abrir para perguntas. Respostas prontas na seção 7 do dossiê.</a:t>
             </a:r>
           </a:p>
         </p:txBody>
@@ -1218,7 +1502,7 @@
           <a:lstStyle/>
           <a:p>
             <a:r>
-              <a:t>[Bruna] O soro é o líquido que sobra no queijo (~9 L para cada 10 L de leite). Tem pouca proteína, mas de alto valor. O WPC tira água, lactose e minerais até 25–89% de proteína; o WPC80 é o dos suplementos. WPI (≥90%) e WPH (hidrolisado) são variações.</a:t>
+              <a:t>[Bruna] O whey nasce de um resíduo. De cada 10 litros de leite que viram queijo, cerca de 9 viram soro. Esse soro leva cerca de 20% das proteínas do leite e é muito poluente se for descartado: DBO de 30 a 60 mil mg/L.</a:t>
             </a:r>
           </a:p>
         </p:txBody>
@@ -1288,7 +1572,7 @@
           <a:lstStyle/>
           <a:p>
             <a:r>
-              <a:t>[Bruna] Classificação: suplemento alimentar (RDC 243/2018), com notificação obrigatória na ANVISA (RDC 843/2024). Como ingrediente, é produto lácteo (MAPA). Saborizado é ultraprocessado (NOVA). Consumo: 59% dos lares com usuário de suplemento (ABIAD 2020) — dado de suplementos em geral, não só whey.</a:t>
+              <a:t>[Bruna] WPC é o soro sem boa parte da água, da lactose e dos minerais, com 25 a 89% de proteína em base seca. O dos suplementos é o WPC80. A matéria-prima é o soro doce, de queijos de coalho. No pote entram também cacau ou aromas, edulcorantes, gomas e lecitina. O isolado (WPI) e o hidrolisado (WPH) são variações.</a:t>
             </a:r>
           </a:p>
         </p:txBody>
@@ -1358,7 +1642,7 @@
           <a:lstStyle/>
           <a:p>
             <a:r>
-              <a:t>[Thiago] WPC80: ~80% de proteína em base seca, 4–10% de lactose. Por isso 30 g dão ~23 g de proteína, não 24 g. Frações: β-lactoglobulina é a maior. PDCAAS 1,0, rico em leucina; ISSN recomenda 20–40 g de proteína por dose.</a:t>
+              <a:t>[Bruna] O mesmo produto tem quatro leituras: para a ANVISA é suplemento alimentar e, desde 1º de setembro de 2026, precisa de notificação; para o MAPA é ingrediente lácteo; tecnologicamente é um pó feito por membranas e secagem; pela classificação NOVA, o saborizado é ultraprocessado.</a:t>
             </a:r>
           </a:p>
         </p:txBody>
@@ -1428,7 +1712,7 @@
           <a:lstStyle/>
           <a:p>
             <a:r>
-              <a:t>[Thiago] Separar o que o rótulo diz do que interpretamos. 23 g de proteína em 30 g = 76,7%; ~75% das calorias vêm da proteína; sem lupa porque não passa dos limites. Mostrar alergênicos, 'contém lactose' e as advertências da RDC 243/2018. (Trocar números se o rótulo fotografado for outro.)</a:t>
+              <a:t>[Bruna] Consumo: em 2020, 59% dos lares tinham alguém usando suplemento (dado de suplementos em geral, não só whey). Os concentrados de proteína cresceram 3% em 2024. Nas academias, a proteína está entre os mais usados, muitas vezes sem orientação de nutricionista. Passo para o Thiago.</a:t>
             </a:r>
           </a:p>
         </p:txBody>
@@ -1498,7 +1782,7 @@
           <a:lstStyle/>
           <a:p>
             <a:r>
-              <a:t>[Gabriel] Parte A, no laticínio: recepção e resfriamento do soro, clarificação, desnate, pasteurização (PCC), ultrafiltração e diafiltração (concentram a proteína), secagem por atomização, aglomeração, peneira e detector de metais (PCC).</a:t>
+              <a:t>[Thiago] O WPC80 tem 80 a 82% de proteína, mas ainda tem lactose: de 4 a 10%. Metade da proteína é beta-lactoglobulina. Por que uma dose de 30 g dá cerca de 23 g de proteína? Porque os 80% são em base seca e o pó saborizado tem umidade e ingredientes de sabor. A qualidade proteica é máxima: PDCAAS 1,0, rica em leucina.</a:t>
             </a:r>
           </a:p>
         </p:txBody>
@@ -1568,7 +1852,7 @@
           <a:lstStyle/>
           <a:p>
             <a:r>
-              <a:t>[Gabriel] Parte B, na indústria de suplementos: recepção, pesagem, mistura com sabor e aditivos, detector de metais, envase, rotulagem e estoque. Destacar: a gota no spray dryer fica fria enquanto evapora. Variações: WPI, WPH, proteína nativa.</a:t>
+              <a:t>[Thiago] Este é o esquema do rótulo que analisamos, com os seis elementos que a lei exige: denominação, tabela nutricional, ingredientes, alergênicos e lactose, as três advertências da RDC 243 e o número de notificação na ANVISA.</a:t>
             </a:r>
           </a:p>
         </p:txBody>
@@ -1638,7 +1922,7 @@
           <a:lstStyle/>
           <a:p>
             <a:r>
-              <a:t>[Renan] Efeitos por tipo, sempre dizendo do que dependem. Mensagem principal: desnaturar não é perder valor nutricional; a reação de Maillard é que reduz a lisina disponível.</a:t>
+              <a:t>[Thiago] Separando o que o rótulo diz do que nós calculamos: 76,7% do pó é proteína; 75% das calorias vêm da proteína; ele não tem lupa porque fica abaixo dos limites; e os 23 g por dose estão dentro da faixa de 20 a 40 g. Passo para o Gabriel.</a:t>
             </a:r>
           </a:p>
         </p:txBody>
@@ -5012,6 +5296,90 @@
 </p:sld>
 </file>
 
+<file path=ppt/slides/slide18.xml><?xml version="1.0" encoding="utf-8"?>
+<p:sld xmlns:a="http://schemas.openxmlformats.org/drawingml/2006/main" xmlns:p="http://schemas.openxmlformats.org/presentationml/2006/main" xmlns:r="http://schemas.openxmlformats.org/officeDocument/2006/relationships">
+  <p:cSld>
+    <p:spTree>
+      <p:nvGrpSpPr>
+        <p:cNvPr id="1" name=""/>
+        <p:cNvGrpSpPr/>
+        <p:nvPr/>
+      </p:nvGrpSpPr>
+      <p:grpSpPr/>
+      <p:pic>
+        <p:nvPicPr>
+          <p:cNvPr id="2" name="Picture 1" descr="s18.jpg"/>
+          <p:cNvPicPr>
+            <a:picLocks noChangeAspect="1"/>
+          </p:cNvPicPr>
+          <p:nvPr/>
+        </p:nvPicPr>
+        <p:blipFill>
+          <a:blip r:embed="rId2"/>
+          <a:stretch>
+            <a:fillRect/>
+          </a:stretch>
+        </p:blipFill>
+        <p:spPr>
+          <a:xfrm>
+            <a:off x="0" y="0"/>
+            <a:ext cx="12192000" cy="6858000"/>
+          </a:xfrm>
+          <a:prstGeom prst="rect">
+            <a:avLst/>
+          </a:prstGeom>
+        </p:spPr>
+      </p:pic>
+    </p:spTree>
+  </p:cSld>
+  <p:clrMapOvr>
+    <a:masterClrMapping/>
+  </p:clrMapOvr>
+</p:sld>
+</file>
+
+<file path=ppt/slides/slide19.xml><?xml version="1.0" encoding="utf-8"?>
+<p:sld xmlns:a="http://schemas.openxmlformats.org/drawingml/2006/main" xmlns:p="http://schemas.openxmlformats.org/presentationml/2006/main" xmlns:r="http://schemas.openxmlformats.org/officeDocument/2006/relationships">
+  <p:cSld>
+    <p:spTree>
+      <p:nvGrpSpPr>
+        <p:cNvPr id="1" name=""/>
+        <p:cNvGrpSpPr/>
+        <p:nvPr/>
+      </p:nvGrpSpPr>
+      <p:grpSpPr/>
+      <p:pic>
+        <p:nvPicPr>
+          <p:cNvPr id="2" name="Picture 1" descr="s19.jpg"/>
+          <p:cNvPicPr>
+            <a:picLocks noChangeAspect="1"/>
+          </p:cNvPicPr>
+          <p:nvPr/>
+        </p:nvPicPr>
+        <p:blipFill>
+          <a:blip r:embed="rId2"/>
+          <a:stretch>
+            <a:fillRect/>
+          </a:stretch>
+        </p:blipFill>
+        <p:spPr>
+          <a:xfrm>
+            <a:off x="0" y="0"/>
+            <a:ext cx="12192000" cy="6858000"/>
+          </a:xfrm>
+          <a:prstGeom prst="rect">
+            <a:avLst/>
+          </a:prstGeom>
+        </p:spPr>
+      </p:pic>
+    </p:spTree>
+  </p:cSld>
+  <p:clrMapOvr>
+    <a:masterClrMapping/>
+  </p:clrMapOvr>
+</p:sld>
+</file>
+
 <file path=ppt/slides/slide2.xml><?xml version="1.0" encoding="utf-8"?>
 <p:sld xmlns:a="http://schemas.openxmlformats.org/drawingml/2006/main" xmlns:p="http://schemas.openxmlformats.org/presentationml/2006/main" xmlns:r="http://schemas.openxmlformats.org/officeDocument/2006/relationships">
   <p:cSld>
@@ -5025,6 +5393,90 @@
       <p:pic>
         <p:nvPicPr>
           <p:cNvPr id="2" name="Picture 1" descr="s02.jpg"/>
+          <p:cNvPicPr>
+            <a:picLocks noChangeAspect="1"/>
+          </p:cNvPicPr>
+          <p:nvPr/>
+        </p:nvPicPr>
+        <p:blipFill>
+          <a:blip r:embed="rId2"/>
+          <a:stretch>
+            <a:fillRect/>
+          </a:stretch>
+        </p:blipFill>
+        <p:spPr>
+          <a:xfrm>
+            <a:off x="0" y="0"/>
+            <a:ext cx="12192000" cy="6858000"/>
+          </a:xfrm>
+          <a:prstGeom prst="rect">
+            <a:avLst/>
+          </a:prstGeom>
+        </p:spPr>
+      </p:pic>
+    </p:spTree>
+  </p:cSld>
+  <p:clrMapOvr>
+    <a:masterClrMapping/>
+  </p:clrMapOvr>
+</p:sld>
+</file>
+
+<file path=ppt/slides/slide20.xml><?xml version="1.0" encoding="utf-8"?>
+<p:sld xmlns:a="http://schemas.openxmlformats.org/drawingml/2006/main" xmlns:p="http://schemas.openxmlformats.org/presentationml/2006/main" xmlns:r="http://schemas.openxmlformats.org/officeDocument/2006/relationships">
+  <p:cSld>
+    <p:spTree>
+      <p:nvGrpSpPr>
+        <p:cNvPr id="1" name=""/>
+        <p:cNvGrpSpPr/>
+        <p:nvPr/>
+      </p:nvGrpSpPr>
+      <p:grpSpPr/>
+      <p:pic>
+        <p:nvPicPr>
+          <p:cNvPr id="2" name="Picture 1" descr="s20.jpg"/>
+          <p:cNvPicPr>
+            <a:picLocks noChangeAspect="1"/>
+          </p:cNvPicPr>
+          <p:nvPr/>
+        </p:nvPicPr>
+        <p:blipFill>
+          <a:blip r:embed="rId2"/>
+          <a:stretch>
+            <a:fillRect/>
+          </a:stretch>
+        </p:blipFill>
+        <p:spPr>
+          <a:xfrm>
+            <a:off x="0" y="0"/>
+            <a:ext cx="12192000" cy="6858000"/>
+          </a:xfrm>
+          <a:prstGeom prst="rect">
+            <a:avLst/>
+          </a:prstGeom>
+        </p:spPr>
+      </p:pic>
+    </p:spTree>
+  </p:cSld>
+  <p:clrMapOvr>
+    <a:masterClrMapping/>
+  </p:clrMapOvr>
+</p:sld>
+</file>
+
+<file path=ppt/slides/slide21.xml><?xml version="1.0" encoding="utf-8"?>
+<p:sld xmlns:a="http://schemas.openxmlformats.org/drawingml/2006/main" xmlns:p="http://schemas.openxmlformats.org/presentationml/2006/main" xmlns:r="http://schemas.openxmlformats.org/officeDocument/2006/relationships">
+  <p:cSld>
+    <p:spTree>
+      <p:nvGrpSpPr>
+        <p:cNvPr id="1" name=""/>
+        <p:cNvGrpSpPr/>
+        <p:nvPr/>
+      </p:nvGrpSpPr>
+      <p:grpSpPr/>
+      <p:pic>
+        <p:nvPicPr>
+          <p:cNvPr id="2" name="Picture 1" descr="s21.jpg"/>
           <p:cNvPicPr>
             <a:picLocks noChangeAspect="1"/>
           </p:cNvPicPr>
@@ -5214,72 +5666,6 @@
           </a:prstGeom>
         </p:spPr>
       </p:pic>
-      <p:sp>
-        <p:nvSpPr>
-          <p:cNvPr id="3" name="Rounded Rectangle 2"/>
-          <p:cNvSpPr/>
-          <p:nvPr/>
-        </p:nvSpPr>
-        <p:spPr>
-          <a:xfrm>
-            <a:off x="609600" y="2168425"/>
-            <a:ext cx="2857500" cy="3981450"/>
-          </a:xfrm>
-          <a:prstGeom prst="roundRect">
-            <a:avLst>
-              <a:gd name="adj" fmla="val 7000"/>
-            </a:avLst>
-          </a:prstGeom>
-          <a:solidFill>
-            <a:srgbClr val="2A0E6B"/>
-          </a:solidFill>
-          <a:ln w="19050">
-            <a:solidFill>
-              <a:srgbClr val="D8B4FE"/>
-            </a:solidFill>
-          </a:ln>
-        </p:spPr>
-        <p:style>
-          <a:lnRef idx="1">
-            <a:schemeClr val="accent1"/>
-          </a:lnRef>
-          <a:fillRef idx="3">
-            <a:schemeClr val="accent1"/>
-          </a:fillRef>
-          <a:effectRef idx="2">
-            <a:schemeClr val="accent1"/>
-          </a:effectRef>
-          <a:fontRef idx="minor">
-            <a:schemeClr val="lt1"/>
-          </a:fontRef>
-        </p:style>
-        <p:txBody>
-          <a:bodyPr rtlCol="0" anchor="ctr" wrap="square"/>
-          <a:lstStyle/>
-          <a:p>
-            <a:pPr algn="ctr"/>
-            <a:r>
-              <a:rPr b="1" sz="1600">
-                <a:solidFill>
-                  <a:srgbClr val="F5F3FF"/>
-                </a:solidFill>
-              </a:rPr>
-              <a:t>FOTO DO RÓTULO</a:t>
-            </a:r>
-          </a:p>
-          <a:p>
-            <a:pPr algn="ctr"/>
-            <a:r>
-              <a:rPr b="0" sz="1100">
-                <a:solidFill>
-                  <a:srgbClr val="F5F3FF"/>
-                </a:solidFill>
-              </a:rPr>
-              <a:t>Inserir &gt; Imagem com a foto do produto analisado e apagar este quadro.</a:t>
-            </a:r>
-          </a:p>
-        </p:txBody>
-      </p:sp>
     </p:spTree>
   </p:cSld>
   <p:clrMapOvr>

</xml_diff>